<commit_message>
Flatsat fully working — all interfaces tested and passing
CAD: CustomBoard SLDASM/SLDPRT, updated FlatSAT assembly and plate, Teensy
4.1 part, and 6 new flatsat support bracket parts (FlySky, laser, screen,
switch, SupportBart, CustomBoardFlatsatSupport). VL53L1X firmware updated,
flash_monitor.py tweaked, connectors.pptx and TODO updated.

Co-Authored-By: Claude Sonnet 4.6 (1M context) <noreply@anthropic.com>
</commit_message>
<xml_diff>
--- a/components/datasheets/custom board/connectors.pptx
+++ b/components/datasheets/custom board/connectors.pptx
@@ -6,6 +6,7 @@
   </p:sldMasterIdLst>
   <p:sldIdLst>
     <p:sldId id="256" r:id="rId2"/>
+    <p:sldId id="257" r:id="rId3"/>
   </p:sldIdLst>
   <p:sldSz cx="12192000" cy="6858000"/>
   <p:notesSz cx="6858000" cy="9144000"/>
@@ -259,7 +260,7 @@
           <a:p>
             <a:fld id="{2ED493E6-7E54-471B-B772-A837C1F2EE02}" type="datetimeFigureOut">
               <a:rPr lang="en-US" smtClean="0"/>
-              <a:t>5/8/2026</a:t>
+              <a:t>5/11/2026</a:t>
             </a:fld>
             <a:endParaRPr lang="en-US"/>
           </a:p>
@@ -457,7 +458,7 @@
           <a:p>
             <a:fld id="{2ED493E6-7E54-471B-B772-A837C1F2EE02}" type="datetimeFigureOut">
               <a:rPr lang="en-US" smtClean="0"/>
-              <a:t>5/8/2026</a:t>
+              <a:t>5/11/2026</a:t>
             </a:fld>
             <a:endParaRPr lang="en-US"/>
           </a:p>
@@ -665,7 +666,7 @@
           <a:p>
             <a:fld id="{2ED493E6-7E54-471B-B772-A837C1F2EE02}" type="datetimeFigureOut">
               <a:rPr lang="en-US" smtClean="0"/>
-              <a:t>5/8/2026</a:t>
+              <a:t>5/11/2026</a:t>
             </a:fld>
             <a:endParaRPr lang="en-US"/>
           </a:p>
@@ -863,7 +864,7 @@
           <a:p>
             <a:fld id="{2ED493E6-7E54-471B-B772-A837C1F2EE02}" type="datetimeFigureOut">
               <a:rPr lang="en-US" smtClean="0"/>
-              <a:t>5/8/2026</a:t>
+              <a:t>5/11/2026</a:t>
             </a:fld>
             <a:endParaRPr lang="en-US"/>
           </a:p>
@@ -1138,7 +1139,7 @@
           <a:p>
             <a:fld id="{2ED493E6-7E54-471B-B772-A837C1F2EE02}" type="datetimeFigureOut">
               <a:rPr lang="en-US" smtClean="0"/>
-              <a:t>5/8/2026</a:t>
+              <a:t>5/11/2026</a:t>
             </a:fld>
             <a:endParaRPr lang="en-US"/>
           </a:p>
@@ -1403,7 +1404,7 @@
           <a:p>
             <a:fld id="{2ED493E6-7E54-471B-B772-A837C1F2EE02}" type="datetimeFigureOut">
               <a:rPr lang="en-US" smtClean="0"/>
-              <a:t>5/8/2026</a:t>
+              <a:t>5/11/2026</a:t>
             </a:fld>
             <a:endParaRPr lang="en-US"/>
           </a:p>
@@ -1815,7 +1816,7 @@
           <a:p>
             <a:fld id="{2ED493E6-7E54-471B-B772-A837C1F2EE02}" type="datetimeFigureOut">
               <a:rPr lang="en-US" smtClean="0"/>
-              <a:t>5/8/2026</a:t>
+              <a:t>5/11/2026</a:t>
             </a:fld>
             <a:endParaRPr lang="en-US"/>
           </a:p>
@@ -1956,7 +1957,7 @@
           <a:p>
             <a:fld id="{2ED493E6-7E54-471B-B772-A837C1F2EE02}" type="datetimeFigureOut">
               <a:rPr lang="en-US" smtClean="0"/>
-              <a:t>5/8/2026</a:t>
+              <a:t>5/11/2026</a:t>
             </a:fld>
             <a:endParaRPr lang="en-US"/>
           </a:p>
@@ -2069,7 +2070,7 @@
           <a:p>
             <a:fld id="{2ED493E6-7E54-471B-B772-A837C1F2EE02}" type="datetimeFigureOut">
               <a:rPr lang="en-US" smtClean="0"/>
-              <a:t>5/8/2026</a:t>
+              <a:t>5/11/2026</a:t>
             </a:fld>
             <a:endParaRPr lang="en-US"/>
           </a:p>
@@ -2380,7 +2381,7 @@
           <a:p>
             <a:fld id="{2ED493E6-7E54-471B-B772-A837C1F2EE02}" type="datetimeFigureOut">
               <a:rPr lang="en-US" smtClean="0"/>
-              <a:t>5/8/2026</a:t>
+              <a:t>5/11/2026</a:t>
             </a:fld>
             <a:endParaRPr lang="en-US"/>
           </a:p>
@@ -2668,7 +2669,7 @@
           <a:p>
             <a:fld id="{2ED493E6-7E54-471B-B772-A837C1F2EE02}" type="datetimeFigureOut">
               <a:rPr lang="en-US" smtClean="0"/>
-              <a:t>5/8/2026</a:t>
+              <a:t>5/11/2026</a:t>
             </a:fld>
             <a:endParaRPr lang="en-US"/>
           </a:p>
@@ -2909,7 +2910,7 @@
           <a:p>
             <a:fld id="{2ED493E6-7E54-471B-B772-A837C1F2EE02}" type="datetimeFigureOut">
               <a:rPr lang="en-US" smtClean="0"/>
-              <a:t>5/8/2026</a:t>
+              <a:t>5/11/2026</a:t>
             </a:fld>
             <a:endParaRPr lang="en-US"/>
           </a:p>
@@ -3326,62 +3327,12 @@
           <a:chExt cx="0" cy="0"/>
         </a:xfrm>
       </p:grpSpPr>
-      <p:sp>
-        <p:nvSpPr>
-          <p:cNvPr id="2" name="Title 1">
-            <a:extLst>
-              <a:ext uri="{FF2B5EF4-FFF2-40B4-BE49-F238E27FC236}">
-                <a16:creationId xmlns:a16="http://schemas.microsoft.com/office/drawing/2014/main" id="{D825998C-482C-2B2A-0B23-14E12950F60B}"/>
-              </a:ext>
-            </a:extLst>
-          </p:cNvPr>
-          <p:cNvSpPr>
-            <a:spLocks noGrp="1"/>
-          </p:cNvSpPr>
-          <p:nvPr>
-            <p:ph type="ctrTitle"/>
-          </p:nvPr>
-        </p:nvSpPr>
-        <p:spPr/>
-        <p:txBody>
-          <a:bodyPr/>
-          <a:lstStyle/>
-          <a:p>
-            <a:endParaRPr lang="en-US"/>
-          </a:p>
-        </p:txBody>
-      </p:sp>
-      <p:sp>
-        <p:nvSpPr>
-          <p:cNvPr id="3" name="Subtitle 2">
-            <a:extLst>
-              <a:ext uri="{FF2B5EF4-FFF2-40B4-BE49-F238E27FC236}">
-                <a16:creationId xmlns:a16="http://schemas.microsoft.com/office/drawing/2014/main" id="{BE3160A1-5014-0210-477E-E00828451782}"/>
-              </a:ext>
-            </a:extLst>
-          </p:cNvPr>
-          <p:cNvSpPr>
-            <a:spLocks noGrp="1"/>
-          </p:cNvSpPr>
-          <p:nvPr>
-            <p:ph type="subTitle" idx="1"/>
-          </p:nvPr>
-        </p:nvSpPr>
-        <p:spPr/>
-        <p:txBody>
-          <a:bodyPr/>
-          <a:lstStyle/>
-          <a:p>
-            <a:endParaRPr lang="en-US"/>
-          </a:p>
-        </p:txBody>
-      </p:sp>
       <p:pic>
         <p:nvPicPr>
-          <p:cNvPr id="5" name="Picture 4">
-            <a:extLst>
-              <a:ext uri="{FF2B5EF4-FFF2-40B4-BE49-F238E27FC236}">
-                <a16:creationId xmlns:a16="http://schemas.microsoft.com/office/drawing/2014/main" id="{F6053224-379E-8309-56C0-F0211FAAE1AE}"/>
+          <p:cNvPr id="19" name="Picture 18">
+            <a:extLst>
+              <a:ext uri="{FF2B5EF4-FFF2-40B4-BE49-F238E27FC236}">
+                <a16:creationId xmlns:a16="http://schemas.microsoft.com/office/drawing/2014/main" id="{383EC535-0220-4DB8-CCE8-2FDB5E1EADD1}"/>
               </a:ext>
             </a:extLst>
           </p:cNvPr>
@@ -3391,15 +3342,22 @@
           <p:nvPr/>
         </p:nvPicPr>
         <p:blipFill>
-          <a:blip r:embed="rId2"/>
+          <a:blip r:embed="rId2">
+            <a:extLst>
+              <a:ext uri="{28A0092B-C50C-407E-A947-70E740481C1C}">
+                <a14:useLocalDpi xmlns:a14="http://schemas.microsoft.com/office/drawing/2010/main" val="0"/>
+              </a:ext>
+            </a:extLst>
+          </a:blip>
+          <a:srcRect l="20261" t="35077" r="22236" b="14897"/>
           <a:stretch>
             <a:fillRect/>
           </a:stretch>
         </p:blipFill>
         <p:spPr>
-          <a:xfrm>
-            <a:off x="2885910" y="568178"/>
-            <a:ext cx="6420180" cy="5721644"/>
+          <a:xfrm rot="16200000">
+            <a:off x="3018661" y="-512527"/>
+            <a:ext cx="6408679" cy="7433734"/>
           </a:xfrm>
           <a:prstGeom prst="rect">
             <a:avLst/>
@@ -3408,10 +3366,10 @@
       </p:pic>
       <p:sp>
         <p:nvSpPr>
-          <p:cNvPr id="6" name="Oval 5">
-            <a:extLst>
-              <a:ext uri="{FF2B5EF4-FFF2-40B4-BE49-F238E27FC236}">
-                <a16:creationId xmlns:a16="http://schemas.microsoft.com/office/drawing/2014/main" id="{434AB061-280B-EECD-4D53-B4364A48B325}"/>
+          <p:cNvPr id="8" name="Rectangle 7">
+            <a:extLst>
+              <a:ext uri="{FF2B5EF4-FFF2-40B4-BE49-F238E27FC236}">
+                <a16:creationId xmlns:a16="http://schemas.microsoft.com/office/drawing/2014/main" id="{EDF3D8D5-A9CB-3FAF-9842-FD2AC853FA44}"/>
               </a:ext>
             </a:extLst>
           </p:cNvPr>
@@ -3420,105 +3378,7 @@
         </p:nvSpPr>
         <p:spPr>
           <a:xfrm>
-            <a:off x="3668888" y="1600200"/>
-            <a:ext cx="1151467" cy="1140178"/>
-          </a:xfrm>
-          <a:prstGeom prst="ellipse">
-            <a:avLst/>
-          </a:prstGeom>
-        </p:spPr>
-        <p:style>
-          <a:lnRef idx="2">
-            <a:schemeClr val="accent1">
-              <a:shade val="15000"/>
-            </a:schemeClr>
-          </a:lnRef>
-          <a:fillRef idx="1">
-            <a:schemeClr val="accent1"/>
-          </a:fillRef>
-          <a:effectRef idx="0">
-            <a:schemeClr val="accent1"/>
-          </a:effectRef>
-          <a:fontRef idx="minor">
-            <a:schemeClr val="lt1"/>
-          </a:fontRef>
-        </p:style>
-        <p:txBody>
-          <a:bodyPr rtlCol="0" anchor="ctr"/>
-          <a:lstStyle/>
-          <a:p>
-            <a:pPr algn="ctr"/>
-            <a:r>
-              <a:rPr lang="en-US" dirty="0"/>
-              <a:t>Buzzer</a:t>
-            </a:r>
-          </a:p>
-        </p:txBody>
-      </p:sp>
-      <p:sp>
-        <p:nvSpPr>
-          <p:cNvPr id="7" name="Rectangle 6">
-            <a:extLst>
-              <a:ext uri="{FF2B5EF4-FFF2-40B4-BE49-F238E27FC236}">
-                <a16:creationId xmlns:a16="http://schemas.microsoft.com/office/drawing/2014/main" id="{5B723815-1342-3DBF-44B1-7B10255E904B}"/>
-              </a:ext>
-            </a:extLst>
-          </p:cNvPr>
-          <p:cNvSpPr/>
-          <p:nvPr/>
-        </p:nvSpPr>
-        <p:spPr>
-          <a:xfrm>
-            <a:off x="3928533" y="3602038"/>
-            <a:ext cx="824089" cy="941740"/>
-          </a:xfrm>
-          <a:prstGeom prst="rect">
-            <a:avLst/>
-          </a:prstGeom>
-        </p:spPr>
-        <p:style>
-          <a:lnRef idx="2">
-            <a:schemeClr val="accent1">
-              <a:shade val="15000"/>
-            </a:schemeClr>
-          </a:lnRef>
-          <a:fillRef idx="1">
-            <a:schemeClr val="accent1"/>
-          </a:fillRef>
-          <a:effectRef idx="0">
-            <a:schemeClr val="accent1"/>
-          </a:effectRef>
-          <a:fontRef idx="minor">
-            <a:schemeClr val="lt1"/>
-          </a:fontRef>
-        </p:style>
-        <p:txBody>
-          <a:bodyPr rtlCol="0" anchor="ctr"/>
-          <a:lstStyle/>
-          <a:p>
-            <a:pPr algn="ctr"/>
-            <a:r>
-              <a:rPr lang="en-US" dirty="0"/>
-              <a:t>CAN 2</a:t>
-            </a:r>
-          </a:p>
-        </p:txBody>
-      </p:sp>
-      <p:sp>
-        <p:nvSpPr>
-          <p:cNvPr id="8" name="Rectangle 7">
-            <a:extLst>
-              <a:ext uri="{FF2B5EF4-FFF2-40B4-BE49-F238E27FC236}">
-                <a16:creationId xmlns:a16="http://schemas.microsoft.com/office/drawing/2014/main" id="{EDF3D8D5-A9CB-3FAF-9842-FD2AC853FA44}"/>
-              </a:ext>
-            </a:extLst>
-          </p:cNvPr>
-          <p:cNvSpPr/>
-          <p:nvPr/>
-        </p:nvSpPr>
-        <p:spPr>
-          <a:xfrm>
-            <a:off x="2626689" y="1858963"/>
+            <a:off x="1932423" y="4115727"/>
             <a:ext cx="790222" cy="457200"/>
           </a:xfrm>
           <a:prstGeom prst="rect">
@@ -3567,8 +3427,8 @@
         </p:nvSpPr>
         <p:spPr>
           <a:xfrm>
-            <a:off x="1941689" y="3373438"/>
-            <a:ext cx="1305889" cy="457200"/>
+            <a:off x="4602139" y="6301676"/>
+            <a:ext cx="1019728" cy="457200"/>
           </a:xfrm>
           <a:prstGeom prst="rect">
             <a:avLst/>
@@ -3620,8 +3480,8 @@
         </p:nvSpPr>
         <p:spPr>
           <a:xfrm>
-            <a:off x="1973744" y="4201319"/>
-            <a:ext cx="1305889" cy="457200"/>
+            <a:off x="2037644" y="2051374"/>
+            <a:ext cx="643679" cy="457200"/>
           </a:xfrm>
           <a:prstGeom prst="rect">
             <a:avLst/>
@@ -3649,9 +3509,10 @@
           <a:p>
             <a:pPr algn="ctr"/>
             <a:r>
-              <a:rPr lang="en-US" dirty="0"/>
-              <a:t>AK45 CAN</a:t>
-            </a:r>
+              <a:rPr lang="en-US" dirty="0" err="1"/>
+              <a:t>ibus</a:t>
+            </a:r>
+            <a:endParaRPr lang="en-US" dirty="0"/>
           </a:p>
         </p:txBody>
       </p:sp>
@@ -3669,8 +3530,8 @@
         </p:nvSpPr>
         <p:spPr>
           <a:xfrm>
-            <a:off x="1973743" y="4800599"/>
-            <a:ext cx="1305889" cy="1227667"/>
+            <a:off x="3048000" y="6257925"/>
+            <a:ext cx="1305889" cy="733777"/>
           </a:xfrm>
           <a:prstGeom prst="rect">
             <a:avLst/>
@@ -3699,22 +3560,7 @@
             <a:pPr algn="ctr"/>
             <a:r>
               <a:rPr lang="en-US" dirty="0"/>
-              <a:t>AK45 UARTs</a:t>
-            </a:r>
-          </a:p>
-          <a:p>
-            <a:pPr algn="ctr"/>
-            <a:endParaRPr lang="en-US" dirty="0"/>
-          </a:p>
-          <a:p>
-            <a:pPr algn="ctr"/>
-            <a:endParaRPr lang="en-US" dirty="0"/>
-          </a:p>
-          <a:p>
-            <a:pPr algn="ctr"/>
-            <a:r>
-              <a:rPr lang="en-US" dirty="0"/>
-              <a:t> x2</a:t>
+              <a:t>AK45 Can + UARTs</a:t>
             </a:r>
           </a:p>
         </p:txBody>
@@ -3733,7 +3579,7 @@
         </p:nvSpPr>
         <p:spPr>
           <a:xfrm>
-            <a:off x="6995489" y="847726"/>
+            <a:off x="6792289" y="6348758"/>
             <a:ext cx="1160734" cy="457200"/>
           </a:xfrm>
           <a:prstGeom prst="rect">
@@ -3763,7 +3609,7 @@
             <a:pPr algn="ctr"/>
             <a:r>
               <a:rPr lang="en-US" dirty="0"/>
-              <a:t>4x lasers</a:t>
+              <a:t>Laser 1</a:t>
             </a:r>
           </a:p>
         </p:txBody>
@@ -3782,7 +3628,7 @@
         </p:nvSpPr>
         <p:spPr>
           <a:xfrm>
-            <a:off x="8928334" y="2316163"/>
+            <a:off x="9849768" y="2801409"/>
             <a:ext cx="1485666" cy="800629"/>
           </a:xfrm>
           <a:prstGeom prst="rect">
@@ -3814,19 +3660,16 @@
               <a:rPr lang="en-US" dirty="0" err="1"/>
               <a:t>Neopixel</a:t>
             </a:r>
-            <a:r>
-              <a:rPr lang="en-US" dirty="0"/>
-              <a:t> or RGB – 4 pinner</a:t>
-            </a:r>
-          </a:p>
-        </p:txBody>
-      </p:sp>
-      <p:sp>
-        <p:nvSpPr>
-          <p:cNvPr id="15" name="Rectangle 14">
-            <a:extLst>
-              <a:ext uri="{FF2B5EF4-FFF2-40B4-BE49-F238E27FC236}">
-                <a16:creationId xmlns:a16="http://schemas.microsoft.com/office/drawing/2014/main" id="{12E14B6A-6A00-91BD-8C5C-E74CD1211126}"/>
+            <a:endParaRPr lang="en-US" dirty="0"/>
+          </a:p>
+        </p:txBody>
+      </p:sp>
+      <p:sp>
+        <p:nvSpPr>
+          <p:cNvPr id="16" name="Rectangle 15">
+            <a:extLst>
+              <a:ext uri="{FF2B5EF4-FFF2-40B4-BE49-F238E27FC236}">
+                <a16:creationId xmlns:a16="http://schemas.microsoft.com/office/drawing/2014/main" id="{3095C305-3B8E-3C78-F4F7-002E1BABBE87}"/>
               </a:ext>
             </a:extLst>
           </p:cNvPr>
@@ -3835,7 +3678,7 @@
         </p:nvSpPr>
         <p:spPr>
           <a:xfrm>
-            <a:off x="8822478" y="3408966"/>
+            <a:off x="9849768" y="943727"/>
             <a:ext cx="1485666" cy="457200"/>
           </a:xfrm>
           <a:prstGeom prst="rect">
@@ -3864,60 +3707,9 @@
           <a:p>
             <a:pPr algn="ctr"/>
             <a:r>
-              <a:rPr lang="en-US" dirty="0" err="1"/>
-              <a:t>Ibus</a:t>
-            </a:r>
-            <a:endParaRPr lang="en-US" dirty="0"/>
-          </a:p>
-        </p:txBody>
-      </p:sp>
-      <p:sp>
-        <p:nvSpPr>
-          <p:cNvPr id="16" name="Rectangle 15">
-            <a:extLst>
-              <a:ext uri="{FF2B5EF4-FFF2-40B4-BE49-F238E27FC236}">
-                <a16:creationId xmlns:a16="http://schemas.microsoft.com/office/drawing/2014/main" id="{3095C305-3B8E-3C78-F4F7-002E1BABBE87}"/>
-              </a:ext>
-            </a:extLst>
-          </p:cNvPr>
-          <p:cNvSpPr/>
-          <p:nvPr/>
-        </p:nvSpPr>
-        <p:spPr>
-          <a:xfrm>
-            <a:off x="8822478" y="4571999"/>
-            <a:ext cx="1485666" cy="457200"/>
-          </a:xfrm>
-          <a:prstGeom prst="rect">
-            <a:avLst/>
-          </a:prstGeom>
-        </p:spPr>
-        <p:style>
-          <a:lnRef idx="2">
-            <a:schemeClr val="accent2">
-              <a:shade val="15000"/>
-            </a:schemeClr>
-          </a:lnRef>
-          <a:fillRef idx="1">
-            <a:schemeClr val="accent2"/>
-          </a:fillRef>
-          <a:effectRef idx="0">
-            <a:schemeClr val="accent2"/>
-          </a:effectRef>
-          <a:fontRef idx="minor">
-            <a:schemeClr val="lt1"/>
-          </a:fontRef>
-        </p:style>
-        <p:txBody>
-          <a:bodyPr rtlCol="0" anchor="ctr"/>
-          <a:lstStyle/>
-          <a:p>
-            <a:pPr algn="ctr"/>
-            <a:r>
-              <a:rPr lang="en-US"/>
-              <a:t>Oled</a:t>
-            </a:r>
-            <a:endParaRPr lang="en-US" dirty="0"/>
+              <a:rPr lang="en-US" dirty="0"/>
+              <a:t>Screen</a:t>
+            </a:r>
           </a:p>
         </p:txBody>
       </p:sp>
@@ -3970,10 +3762,429 @@
           </a:p>
         </p:txBody>
       </p:sp>
+      <p:sp>
+        <p:nvSpPr>
+          <p:cNvPr id="17" name="TextBox 16">
+            <a:extLst>
+              <a:ext uri="{FF2B5EF4-FFF2-40B4-BE49-F238E27FC236}">
+                <a16:creationId xmlns:a16="http://schemas.microsoft.com/office/drawing/2014/main" id="{88386EE5-44B2-2A1C-EEC5-701FBC018E4D}"/>
+              </a:ext>
+            </a:extLst>
+          </p:cNvPr>
+          <p:cNvSpPr txBox="1"/>
+          <p:nvPr/>
+        </p:nvSpPr>
+        <p:spPr>
+          <a:xfrm>
+            <a:off x="3048000" y="3244334"/>
+            <a:ext cx="6096000" cy="369332"/>
+          </a:xfrm>
+          <a:prstGeom prst="rect">
+            <a:avLst/>
+          </a:prstGeom>
+          <a:noFill/>
+        </p:spPr>
+        <p:txBody>
+          <a:bodyPr wrap="square">
+            <a:spAutoFit/>
+          </a:bodyPr>
+          <a:lstStyle/>
+          <a:p>
+            <a:endParaRPr lang="en-US" dirty="0"/>
+          </a:p>
+        </p:txBody>
+      </p:sp>
+      <p:sp>
+        <p:nvSpPr>
+          <p:cNvPr id="20" name="Rectangle 19">
+            <a:extLst>
+              <a:ext uri="{FF2B5EF4-FFF2-40B4-BE49-F238E27FC236}">
+                <a16:creationId xmlns:a16="http://schemas.microsoft.com/office/drawing/2014/main" id="{1C05BE62-A327-3EF7-72C1-A9C76E211CF3}"/>
+              </a:ext>
+            </a:extLst>
+          </p:cNvPr>
+          <p:cNvSpPr/>
+          <p:nvPr/>
+        </p:nvSpPr>
+        <p:spPr>
+          <a:xfrm>
+            <a:off x="6690689" y="4779712"/>
+            <a:ext cx="1160734" cy="457200"/>
+          </a:xfrm>
+          <a:prstGeom prst="rect">
+            <a:avLst/>
+          </a:prstGeom>
+        </p:spPr>
+        <p:style>
+          <a:lnRef idx="2">
+            <a:schemeClr val="accent2">
+              <a:shade val="15000"/>
+            </a:schemeClr>
+          </a:lnRef>
+          <a:fillRef idx="1">
+            <a:schemeClr val="accent2"/>
+          </a:fillRef>
+          <a:effectRef idx="0">
+            <a:schemeClr val="accent2"/>
+          </a:effectRef>
+          <a:fontRef idx="minor">
+            <a:schemeClr val="lt1"/>
+          </a:fontRef>
+        </p:style>
+        <p:txBody>
+          <a:bodyPr rtlCol="0" anchor="ctr"/>
+          <a:lstStyle/>
+          <a:p>
+            <a:pPr algn="ctr"/>
+            <a:r>
+              <a:rPr lang="en-US" dirty="0"/>
+              <a:t>Laser 3</a:t>
+            </a:r>
+          </a:p>
+        </p:txBody>
+      </p:sp>
+      <p:sp>
+        <p:nvSpPr>
+          <p:cNvPr id="21" name="Rectangle 20">
+            <a:extLst>
+              <a:ext uri="{FF2B5EF4-FFF2-40B4-BE49-F238E27FC236}">
+                <a16:creationId xmlns:a16="http://schemas.microsoft.com/office/drawing/2014/main" id="{878DD090-657F-3A22-8704-90ED6DCCDC0C}"/>
+              </a:ext>
+            </a:extLst>
+          </p:cNvPr>
+          <p:cNvSpPr/>
+          <p:nvPr/>
+        </p:nvSpPr>
+        <p:spPr>
+          <a:xfrm>
+            <a:off x="8485412" y="6334484"/>
+            <a:ext cx="1160734" cy="457200"/>
+          </a:xfrm>
+          <a:prstGeom prst="rect">
+            <a:avLst/>
+          </a:prstGeom>
+        </p:spPr>
+        <p:style>
+          <a:lnRef idx="2">
+            <a:schemeClr val="accent2">
+              <a:shade val="15000"/>
+            </a:schemeClr>
+          </a:lnRef>
+          <a:fillRef idx="1">
+            <a:schemeClr val="accent2"/>
+          </a:fillRef>
+          <a:effectRef idx="0">
+            <a:schemeClr val="accent2"/>
+          </a:effectRef>
+          <a:fontRef idx="minor">
+            <a:schemeClr val="lt1"/>
+          </a:fontRef>
+        </p:style>
+        <p:txBody>
+          <a:bodyPr rtlCol="0" anchor="ctr"/>
+          <a:lstStyle/>
+          <a:p>
+            <a:pPr algn="ctr"/>
+            <a:r>
+              <a:rPr lang="en-US" dirty="0"/>
+              <a:t>Laser 2</a:t>
+            </a:r>
+          </a:p>
+        </p:txBody>
+      </p:sp>
+      <p:sp>
+        <p:nvSpPr>
+          <p:cNvPr id="22" name="Rectangle 21">
+            <a:extLst>
+              <a:ext uri="{FF2B5EF4-FFF2-40B4-BE49-F238E27FC236}">
+                <a16:creationId xmlns:a16="http://schemas.microsoft.com/office/drawing/2014/main" id="{EE5D2E64-9448-535E-B60E-FAB953320525}"/>
+              </a:ext>
+            </a:extLst>
+          </p:cNvPr>
+          <p:cNvSpPr/>
+          <p:nvPr/>
+        </p:nvSpPr>
+        <p:spPr>
+          <a:xfrm>
+            <a:off x="8435243" y="4781402"/>
+            <a:ext cx="1160734" cy="457200"/>
+          </a:xfrm>
+          <a:prstGeom prst="rect">
+            <a:avLst/>
+          </a:prstGeom>
+        </p:spPr>
+        <p:style>
+          <a:lnRef idx="2">
+            <a:schemeClr val="accent2">
+              <a:shade val="15000"/>
+            </a:schemeClr>
+          </a:lnRef>
+          <a:fillRef idx="1">
+            <a:schemeClr val="accent2"/>
+          </a:fillRef>
+          <a:effectRef idx="0">
+            <a:schemeClr val="accent2"/>
+          </a:effectRef>
+          <a:fontRef idx="minor">
+            <a:schemeClr val="lt1"/>
+          </a:fontRef>
+        </p:style>
+        <p:txBody>
+          <a:bodyPr rtlCol="0" anchor="ctr"/>
+          <a:lstStyle/>
+          <a:p>
+            <a:pPr algn="ctr"/>
+            <a:r>
+              <a:rPr lang="en-US" dirty="0"/>
+              <a:t>Laser 4</a:t>
+            </a:r>
+          </a:p>
+        </p:txBody>
+      </p:sp>
+      <p:sp>
+        <p:nvSpPr>
+          <p:cNvPr id="23" name="Rectangle 22">
+            <a:extLst>
+              <a:ext uri="{FF2B5EF4-FFF2-40B4-BE49-F238E27FC236}">
+                <a16:creationId xmlns:a16="http://schemas.microsoft.com/office/drawing/2014/main" id="{CBB8B404-A5B8-6DC6-E492-F50F8FF9597B}"/>
+              </a:ext>
+            </a:extLst>
+          </p:cNvPr>
+          <p:cNvSpPr/>
+          <p:nvPr/>
+        </p:nvSpPr>
+        <p:spPr>
+          <a:xfrm>
+            <a:off x="5728817" y="6301676"/>
+            <a:ext cx="790222" cy="457200"/>
+          </a:xfrm>
+          <a:prstGeom prst="rect">
+            <a:avLst/>
+          </a:prstGeom>
+        </p:spPr>
+        <p:style>
+          <a:lnRef idx="2">
+            <a:schemeClr val="accent2">
+              <a:shade val="15000"/>
+            </a:schemeClr>
+          </a:lnRef>
+          <a:fillRef idx="1">
+            <a:schemeClr val="accent2"/>
+          </a:fillRef>
+          <a:effectRef idx="0">
+            <a:schemeClr val="accent2"/>
+          </a:effectRef>
+          <a:fontRef idx="minor">
+            <a:schemeClr val="lt1"/>
+          </a:fontRef>
+        </p:style>
+        <p:txBody>
+          <a:bodyPr rtlCol="0" anchor="ctr"/>
+          <a:lstStyle/>
+          <a:p>
+            <a:pPr algn="ctr"/>
+            <a:r>
+              <a:rPr lang="en-US" dirty="0"/>
+              <a:t>+5V in</a:t>
+            </a:r>
+          </a:p>
+        </p:txBody>
+      </p:sp>
+      <p:sp>
+        <p:nvSpPr>
+          <p:cNvPr id="24" name="Rectangle 23">
+            <a:extLst>
+              <a:ext uri="{FF2B5EF4-FFF2-40B4-BE49-F238E27FC236}">
+                <a16:creationId xmlns:a16="http://schemas.microsoft.com/office/drawing/2014/main" id="{AA716786-027A-C659-C237-E9FC5C3DF606}"/>
+              </a:ext>
+            </a:extLst>
+          </p:cNvPr>
+          <p:cNvSpPr/>
+          <p:nvPr/>
+        </p:nvSpPr>
+        <p:spPr>
+          <a:xfrm>
+            <a:off x="1715911" y="854752"/>
+            <a:ext cx="877817" cy="613600"/>
+          </a:xfrm>
+          <a:prstGeom prst="rect">
+            <a:avLst/>
+          </a:prstGeom>
+        </p:spPr>
+        <p:style>
+          <a:lnRef idx="2">
+            <a:schemeClr val="accent2">
+              <a:shade val="15000"/>
+            </a:schemeClr>
+          </a:lnRef>
+          <a:fillRef idx="1">
+            <a:schemeClr val="accent2"/>
+          </a:fillRef>
+          <a:effectRef idx="0">
+            <a:schemeClr val="accent2"/>
+          </a:effectRef>
+          <a:fontRef idx="minor">
+            <a:schemeClr val="lt1"/>
+          </a:fontRef>
+        </p:style>
+        <p:txBody>
+          <a:bodyPr rtlCol="0" anchor="ctr"/>
+          <a:lstStyle/>
+          <a:p>
+            <a:pPr algn="ctr"/>
+            <a:r>
+              <a:rPr lang="en-US" dirty="0"/>
+              <a:t>RGB LED</a:t>
+            </a:r>
+          </a:p>
+        </p:txBody>
+      </p:sp>
+      <p:sp>
+        <p:nvSpPr>
+          <p:cNvPr id="25" name="Rectangle 24">
+            <a:extLst>
+              <a:ext uri="{FF2B5EF4-FFF2-40B4-BE49-F238E27FC236}">
+                <a16:creationId xmlns:a16="http://schemas.microsoft.com/office/drawing/2014/main" id="{A187FE82-4A8A-C5BA-A6C0-CDB344A7BB61}"/>
+              </a:ext>
+            </a:extLst>
+          </p:cNvPr>
+          <p:cNvSpPr/>
+          <p:nvPr/>
+        </p:nvSpPr>
+        <p:spPr>
+          <a:xfrm>
+            <a:off x="3175850" y="60393"/>
+            <a:ext cx="877817" cy="388927"/>
+          </a:xfrm>
+          <a:prstGeom prst="rect">
+            <a:avLst/>
+          </a:prstGeom>
+        </p:spPr>
+        <p:style>
+          <a:lnRef idx="2">
+            <a:schemeClr val="accent2">
+              <a:shade val="15000"/>
+            </a:schemeClr>
+          </a:lnRef>
+          <a:fillRef idx="1">
+            <a:schemeClr val="accent2"/>
+          </a:fillRef>
+          <a:effectRef idx="0">
+            <a:schemeClr val="accent2"/>
+          </a:effectRef>
+          <a:fontRef idx="minor">
+            <a:schemeClr val="lt1"/>
+          </a:fontRef>
+        </p:style>
+        <p:txBody>
+          <a:bodyPr rtlCol="0" anchor="ctr"/>
+          <a:lstStyle/>
+          <a:p>
+            <a:pPr algn="ctr"/>
+            <a:r>
+              <a:rPr lang="en-US" dirty="0"/>
+              <a:t>Buzzer</a:t>
+            </a:r>
+          </a:p>
+        </p:txBody>
+      </p:sp>
     </p:spTree>
     <p:extLst>
       <p:ext uri="{BB962C8B-B14F-4D97-AF65-F5344CB8AC3E}">
         <p14:creationId xmlns:p14="http://schemas.microsoft.com/office/powerpoint/2010/main" val="27730407"/>
+      </p:ext>
+    </p:extLst>
+  </p:cSld>
+  <p:clrMapOvr>
+    <a:masterClrMapping/>
+  </p:clrMapOvr>
+</p:sld>
+</file>
+
+<file path=ppt/slides/slide2.xml><?xml version="1.0" encoding="utf-8"?>
+<p:sld xmlns:a="http://schemas.openxmlformats.org/drawingml/2006/main" xmlns:r="http://schemas.openxmlformats.org/officeDocument/2006/relationships" xmlns:p="http://schemas.openxmlformats.org/presentationml/2006/main">
+  <p:cSld>
+    <p:spTree>
+      <p:nvGrpSpPr>
+        <p:cNvPr id="1" name=""/>
+        <p:cNvGrpSpPr/>
+        <p:nvPr/>
+      </p:nvGrpSpPr>
+      <p:grpSpPr>
+        <a:xfrm>
+          <a:off x="0" y="0"/>
+          <a:ext cx="0" cy="0"/>
+          <a:chOff x="0" y="0"/>
+          <a:chExt cx="0" cy="0"/>
+        </a:xfrm>
+      </p:grpSpPr>
+      <p:sp>
+        <p:nvSpPr>
+          <p:cNvPr id="2" name="Title 1">
+            <a:extLst>
+              <a:ext uri="{FF2B5EF4-FFF2-40B4-BE49-F238E27FC236}">
+                <a16:creationId xmlns:a16="http://schemas.microsoft.com/office/drawing/2014/main" id="{5730B9D5-9793-C5A6-54E7-669274FA7A85}"/>
+              </a:ext>
+            </a:extLst>
+          </p:cNvPr>
+          <p:cNvSpPr>
+            <a:spLocks noGrp="1"/>
+          </p:cNvSpPr>
+          <p:nvPr>
+            <p:ph type="title"/>
+          </p:nvPr>
+        </p:nvSpPr>
+        <p:spPr/>
+        <p:txBody>
+          <a:bodyPr/>
+          <a:lstStyle/>
+          <a:p>
+            <a:endParaRPr lang="en-US"/>
+          </a:p>
+        </p:txBody>
+      </p:sp>
+      <p:pic>
+        <p:nvPicPr>
+          <p:cNvPr id="5" name="Content Placeholder 4">
+            <a:extLst>
+              <a:ext uri="{FF2B5EF4-FFF2-40B4-BE49-F238E27FC236}">
+                <a16:creationId xmlns:a16="http://schemas.microsoft.com/office/drawing/2014/main" id="{5EC1E5D4-FF5B-B6DA-C815-415D2B15C693}"/>
+              </a:ext>
+            </a:extLst>
+          </p:cNvPr>
+          <p:cNvPicPr>
+            <a:picLocks noGrp="1" noChangeAspect="1"/>
+          </p:cNvPicPr>
+          <p:nvPr>
+            <p:ph idx="1"/>
+          </p:nvPr>
+        </p:nvPicPr>
+        <p:blipFill>
+          <a:blip r:embed="rId2">
+            <a:extLst>
+              <a:ext uri="{28A0092B-C50C-407E-A947-70E740481C1C}">
+                <a14:useLocalDpi xmlns:a14="http://schemas.microsoft.com/office/drawing/2010/main" val="0"/>
+              </a:ext>
+            </a:extLst>
+          </a:blip>
+          <a:stretch>
+            <a:fillRect/>
+          </a:stretch>
+        </p:blipFill>
+        <p:spPr>
+          <a:xfrm rot="16200000">
+            <a:off x="2150533" y="-1095640"/>
+            <a:ext cx="6637868" cy="8850488"/>
+          </a:xfrm>
+          <a:prstGeom prst="rect">
+            <a:avLst/>
+          </a:prstGeom>
+        </p:spPr>
+      </p:pic>
+    </p:spTree>
+    <p:extLst>
+      <p:ext uri="{BB962C8B-B14F-4D97-AF65-F5344CB8AC3E}">
+        <p14:creationId xmlns:p14="http://schemas.microsoft.com/office/powerpoint/2010/main" val="846442186"/>
       </p:ext>
     </p:extLst>
   </p:cSld>

</xml_diff>